<commit_message>
done presentation and code
</commit_message>
<xml_diff>
--- a/BrainTumorSegmentation_Presentation.pptx
+++ b/BrainTumorSegmentation_Presentation.pptx
@@ -25,8 +25,9 @@
     <p:sldId id="264" r:id="rId19"/>
     <p:sldId id="268" r:id="rId20"/>
     <p:sldId id="280" r:id="rId21"/>
-    <p:sldId id="271" r:id="rId22"/>
-    <p:sldId id="272" r:id="rId23"/>
+    <p:sldId id="281" r:id="rId22"/>
+    <p:sldId id="271" r:id="rId23"/>
+    <p:sldId id="272" r:id="rId24"/>
   </p:sldIdLst>
   <p:sldSz cx="9144000" cy="6858000" type="screen4x3"/>
   <p:notesSz cx="6858000" cy="9144000"/>
@@ -307,7 +308,7 @@
           <a:p>
             <a:fld id="{5BCAD085-E8A6-8845-BD4E-CB4CCA059FC4}" type="datetimeFigureOut">
               <a:rPr lang="en-US" smtClean="0"/>
-              <a:t>6/1/2025</a:t>
+              <a:t>6/2/2025</a:t>
             </a:fld>
             <a:endParaRPr lang="en-US"/>
           </a:p>
@@ -477,7 +478,7 @@
           <a:p>
             <a:fld id="{5BCAD085-E8A6-8845-BD4E-CB4CCA059FC4}" type="datetimeFigureOut">
               <a:rPr lang="en-US" smtClean="0"/>
-              <a:t>6/1/2025</a:t>
+              <a:t>6/2/2025</a:t>
             </a:fld>
             <a:endParaRPr lang="en-US"/>
           </a:p>
@@ -657,7 +658,7 @@
           <a:p>
             <a:fld id="{5BCAD085-E8A6-8845-BD4E-CB4CCA059FC4}" type="datetimeFigureOut">
               <a:rPr lang="en-US" smtClean="0"/>
-              <a:t>6/1/2025</a:t>
+              <a:t>6/2/2025</a:t>
             </a:fld>
             <a:endParaRPr lang="en-US"/>
           </a:p>
@@ -827,7 +828,7 @@
           <a:p>
             <a:fld id="{5BCAD085-E8A6-8845-BD4E-CB4CCA059FC4}" type="datetimeFigureOut">
               <a:rPr lang="en-US" smtClean="0"/>
-              <a:t>6/1/2025</a:t>
+              <a:t>6/2/2025</a:t>
             </a:fld>
             <a:endParaRPr lang="en-US"/>
           </a:p>
@@ -1095,7 +1096,7 @@
           <a:p>
             <a:fld id="{5BCAD085-E8A6-8845-BD4E-CB4CCA059FC4}" type="datetimeFigureOut">
               <a:rPr lang="en-US" smtClean="0"/>
-              <a:t>6/1/2025</a:t>
+              <a:t>6/2/2025</a:t>
             </a:fld>
             <a:endParaRPr lang="en-US"/>
           </a:p>
@@ -1327,7 +1328,7 @@
           <a:p>
             <a:fld id="{5BCAD085-E8A6-8845-BD4E-CB4CCA059FC4}" type="datetimeFigureOut">
               <a:rPr lang="en-US" smtClean="0"/>
-              <a:t>6/1/2025</a:t>
+              <a:t>6/2/2025</a:t>
             </a:fld>
             <a:endParaRPr lang="en-US"/>
           </a:p>
@@ -1686,7 +1687,7 @@
           <a:p>
             <a:fld id="{5BCAD085-E8A6-8845-BD4E-CB4CCA059FC4}" type="datetimeFigureOut">
               <a:rPr lang="en-US" smtClean="0"/>
-              <a:t>6/1/2025</a:t>
+              <a:t>6/2/2025</a:t>
             </a:fld>
             <a:endParaRPr lang="en-US"/>
           </a:p>
@@ -1827,7 +1828,7 @@
           <a:p>
             <a:fld id="{5BCAD085-E8A6-8845-BD4E-CB4CCA059FC4}" type="datetimeFigureOut">
               <a:rPr lang="en-US" smtClean="0"/>
-              <a:t>6/1/2025</a:t>
+              <a:t>6/2/2025</a:t>
             </a:fld>
             <a:endParaRPr lang="en-US"/>
           </a:p>
@@ -1922,7 +1923,7 @@
           <a:p>
             <a:fld id="{5BCAD085-E8A6-8845-BD4E-CB4CCA059FC4}" type="datetimeFigureOut">
               <a:rPr lang="en-US" smtClean="0"/>
-              <a:t>6/1/2025</a:t>
+              <a:t>6/2/2025</a:t>
             </a:fld>
             <a:endParaRPr lang="en-US"/>
           </a:p>
@@ -2279,7 +2280,7 @@
           <a:p>
             <a:fld id="{5BCAD085-E8A6-8845-BD4E-CB4CCA059FC4}" type="datetimeFigureOut">
               <a:rPr lang="en-US" smtClean="0"/>
-              <a:t>6/1/2025</a:t>
+              <a:t>6/2/2025</a:t>
             </a:fld>
             <a:endParaRPr lang="en-US"/>
           </a:p>
@@ -2638,7 +2639,7 @@
           <a:p>
             <a:fld id="{5BCAD085-E8A6-8845-BD4E-CB4CCA059FC4}" type="datetimeFigureOut">
               <a:rPr lang="en-US" smtClean="0"/>
-              <a:t>6/1/2025</a:t>
+              <a:t>6/2/2025</a:t>
             </a:fld>
             <a:endParaRPr lang="en-US"/>
           </a:p>
@@ -2882,7 +2883,7 @@
           <a:p>
             <a:fld id="{5BCAD085-E8A6-8845-BD4E-CB4CCA059FC4}" type="datetimeFigureOut">
               <a:rPr lang="en-US" smtClean="0"/>
-              <a:t>6/1/2025</a:t>
+              <a:t>6/2/2025</a:t>
             </a:fld>
             <a:endParaRPr lang="en-US"/>
           </a:p>
@@ -3347,13 +3348,13 @@
         <p:spPr/>
         <p:txBody>
           <a:bodyPr>
-            <a:normAutofit fontScale="90000"/>
+            <a:normAutofit/>
           </a:bodyPr>
           <a:lstStyle/>
           <a:p>
             <a:r>
               <a:rPr dirty="0"/>
-              <a:t>Brain Tumor Segmentation with 2D U-Net</a:t>
+              <a:t>Brain Tumor Segmentation</a:t>
             </a:r>
           </a:p>
         </p:txBody>
@@ -3376,35 +3377,28 @@
         </p:spPr>
         <p:txBody>
           <a:bodyPr>
-            <a:normAutofit/>
+            <a:noAutofit/>
           </a:bodyPr>
           <a:lstStyle/>
           <a:p>
-            <a:r>
-              <a:rPr dirty="0"/>
-              <a:t>Semantic Segmentation on BRATS Dataset</a:t>
-            </a:r>
-            <a:endParaRPr lang="ro-RO" dirty="0"/>
-          </a:p>
-          <a:p>
-            <a:endParaRPr lang="ro-RO" dirty="0"/>
-          </a:p>
-          <a:p>
-            <a:endParaRPr lang="ro-RO" dirty="0"/>
-          </a:p>
-          <a:p>
-            <a:endParaRPr lang="ro-RO" dirty="0"/>
-          </a:p>
-          <a:p>
-            <a:endParaRPr lang="ro-RO" dirty="0"/>
+            <a:endParaRPr lang="en-US" sz="2000" dirty="0"/>
+          </a:p>
+          <a:p>
+            <a:endParaRPr lang="ro-RO" sz="2000" dirty="0"/>
+          </a:p>
+          <a:p>
+            <a:endParaRPr lang="ro-RO" sz="2000" dirty="0"/>
+          </a:p>
+          <a:p>
+            <a:endParaRPr lang="ro-RO" sz="2000" dirty="0"/>
           </a:p>
           <a:p>
             <a:pPr algn="r"/>
             <a:r>
-              <a:rPr lang="ro-RO" dirty="0"/>
+              <a:rPr lang="ro-RO" sz="2000" dirty="0"/>
               <a:t>Adrian-Valentin Ciu</a:t>
             </a:r>
-            <a:endParaRPr dirty="0"/>
+            <a:endParaRPr sz="2000" dirty="0"/>
           </a:p>
         </p:txBody>
       </p:sp>
@@ -4670,7 +4664,13 @@
             </a:r>
             <a:r>
               <a:rPr lang="en-US" sz="2200" dirty="0"/>
-              <a:t> ~70GB</a:t>
+              <a:t> ~70GB  (32GB after prepressing)</a:t>
+            </a:r>
+          </a:p>
+          <a:p>
+            <a:r>
+              <a:rPr lang="en-US" sz="2200" dirty="0"/>
+              <a:t>~ 550 volumes (~ 34000 slices)</a:t>
             </a:r>
             <a:endParaRPr sz="2200" dirty="0"/>
           </a:p>
@@ -4793,6 +4793,117 @@
       </p:grpSpPr>
       <p:sp>
         <p:nvSpPr>
+          <p:cNvPr id="2" name="Title 1">
+            <a:extLst>
+              <a:ext uri="{FF2B5EF4-FFF2-40B4-BE49-F238E27FC236}">
+                <a16:creationId xmlns:a16="http://schemas.microsoft.com/office/drawing/2014/main" id="{591E7B38-AE48-9735-BFAC-DF9D5762DC68}"/>
+              </a:ext>
+            </a:extLst>
+          </p:cNvPr>
+          <p:cNvSpPr>
+            <a:spLocks noGrp="1"/>
+          </p:cNvSpPr>
+          <p:nvPr>
+            <p:ph type="title"/>
+          </p:nvPr>
+        </p:nvSpPr>
+        <p:spPr/>
+        <p:txBody>
+          <a:bodyPr/>
+          <a:lstStyle/>
+          <a:p>
+            <a:r>
+              <a:rPr lang="en-US" dirty="0"/>
+              <a:t>HARDWARE</a:t>
+            </a:r>
+          </a:p>
+        </p:txBody>
+      </p:sp>
+      <p:sp>
+        <p:nvSpPr>
+          <p:cNvPr id="3" name="Content Placeholder 2">
+            <a:extLst>
+              <a:ext uri="{FF2B5EF4-FFF2-40B4-BE49-F238E27FC236}">
+                <a16:creationId xmlns:a16="http://schemas.microsoft.com/office/drawing/2014/main" id="{6973B2FA-6BAD-B41F-1E5F-3011FFDD7A88}"/>
+              </a:ext>
+            </a:extLst>
+          </p:cNvPr>
+          <p:cNvSpPr>
+            <a:spLocks noGrp="1"/>
+          </p:cNvSpPr>
+          <p:nvPr>
+            <p:ph idx="1"/>
+          </p:nvPr>
+        </p:nvSpPr>
+        <p:spPr/>
+        <p:txBody>
+          <a:bodyPr>
+            <a:normAutofit/>
+          </a:bodyPr>
+          <a:lstStyle/>
+          <a:p>
+            <a:r>
+              <a:rPr lang="en-US" sz="2200" dirty="0"/>
+              <a:t>Nvidia RTX 3090</a:t>
+            </a:r>
+          </a:p>
+          <a:p>
+            <a:r>
+              <a:rPr lang="en-US" sz="2200" dirty="0"/>
+              <a:t>Intel </a:t>
+            </a:r>
+            <a:r>
+              <a:rPr lang="en-US" sz="2200" i="1" dirty="0"/>
+              <a:t>I</a:t>
+            </a:r>
+            <a:r>
+              <a:rPr lang="en-US" sz="2200" dirty="0"/>
+              <a:t>9</a:t>
+            </a:r>
+          </a:p>
+          <a:p>
+            <a:r>
+              <a:rPr lang="en-US" sz="2200" dirty="0"/>
+              <a:t>32 GB RAM</a:t>
+            </a:r>
+          </a:p>
+          <a:p>
+            <a:endParaRPr lang="en-US" sz="2200" dirty="0"/>
+          </a:p>
+        </p:txBody>
+      </p:sp>
+    </p:spTree>
+    <p:extLst>
+      <p:ext uri="{BB962C8B-B14F-4D97-AF65-F5344CB8AC3E}">
+        <p14:creationId xmlns:p14="http://schemas.microsoft.com/office/powerpoint/2010/main" val="1643391034"/>
+      </p:ext>
+    </p:extLst>
+  </p:cSld>
+  <p:clrMapOvr>
+    <a:masterClrMapping/>
+  </p:clrMapOvr>
+</p:sld>
+</file>
+
+<file path=ppt/slides/slide22.xml><?xml version="1.0" encoding="utf-8"?>
+<p:sld xmlns:a="http://schemas.openxmlformats.org/drawingml/2006/main" xmlns:r="http://schemas.openxmlformats.org/officeDocument/2006/relationships" xmlns:p="http://schemas.openxmlformats.org/presentationml/2006/main">
+  <p:cSld>
+    <p:spTree>
+      <p:nvGrpSpPr>
+        <p:cNvPr id="1" name=""/>
+        <p:cNvGrpSpPr/>
+        <p:nvPr/>
+      </p:nvGrpSpPr>
+      <p:grpSpPr>
+        <a:xfrm>
+          <a:off x="0" y="0"/>
+          <a:ext cx="0" cy="0"/>
+          <a:chOff x="0" y="0"/>
+          <a:chExt cx="0" cy="0"/>
+        </a:xfrm>
+      </p:grpSpPr>
+      <p:sp>
+        <p:nvSpPr>
           <p:cNvPr id="2" name="Title 1"/>
           <p:cNvSpPr>
             <a:spLocks noGrp="1"/>
@@ -4869,7 +4980,7 @@
 </p:sld>
 </file>
 
-<file path=ppt/slides/slide22.xml><?xml version="1.0" encoding="utf-8"?>
+<file path=ppt/slides/slide23.xml><?xml version="1.0" encoding="utf-8"?>
 <p:sld xmlns:a="http://schemas.openxmlformats.org/drawingml/2006/main" xmlns:r="http://schemas.openxmlformats.org/officeDocument/2006/relationships" xmlns:p="http://schemas.openxmlformats.org/presentationml/2006/main">
   <p:cSld>
     <p:spTree>
@@ -5296,7 +5407,7 @@
           <a:p>
             <a:r>
               <a:rPr sz="2000" dirty="0"/>
-              <a:t>Resized to 256x256 (required for U-Net with pretrained encoders)</a:t>
+              <a:t>Resized to 256x256</a:t>
             </a:r>
           </a:p>
           <a:p>

</xml_diff>